<commit_message>
Add poster figures and update architecture scripts
Add numerous poster assets and figure sources, remove an old PPTX, and improve architecture figure generation. New files include updated presentation exports (V4.pdf, V4 larger text.pptx), several poster/_figs PNGs (architecture, parity plots, feature importance, walk-forward, micro-climate accuracy), and generator scripts poster/_make_arch_v8.py and poster/_make_text_large_figures.py. Updated poster/_make_architecture.py to use improved text autoscaling and layout logic; also updated the V4.pptx binary. OLD presentation file was removed.
</commit_message>
<xml_diff>
--- a/poster/Predictive Modeling of Root-Zone Variables Using Greenhouse Data - Project 14 V4.pptx
+++ b/poster/Predictive Modeling of Root-Zone Variables Using Greenhouse Data - Project 14 V4.pptx
@@ -257,7 +257,7 @@
             <a:fld id="{0158C5BC-9A70-462C-B28D-9600239EAC64}" type="datetimeFigureOut">
               <a:rPr lang="en-US" smtClean="0"/>
               <a:pPr/>
-              <a:t>6/9/2026</a:t>
+              <a:t>6/10/2026</a:t>
             </a:fld>
             <a:endParaRPr lang="en-US"/>
           </a:p>
@@ -424,7 +424,7 @@
             <a:fld id="{E6CC2317-6751-4CD4-9995-8782DD78E936}" type="datetimeFigureOut">
               <a:rPr lang="en-US" smtClean="0"/>
               <a:pPr/>
-              <a:t>6/9/2026</a:t>
+              <a:t>6/10/2026</a:t>
             </a:fld>
             <a:endParaRPr lang="en-US" dirty="0"/>
           </a:p>
@@ -16312,10 +16312,10 @@
       </p:sp>
       <p:pic>
         <p:nvPicPr>
-          <p:cNvPr id="46" name="תמונה 45">
+          <p:cNvPr id="48" name="תמונה 47">
             <a:extLst>
               <a:ext uri="{FF2B5EF4-FFF2-40B4-BE49-F238E27FC236}">
-                <a16:creationId xmlns:a16="http://schemas.microsoft.com/office/drawing/2014/main" id="{0DE69F8B-B277-BF13-55D1-24DFA47E42EE}"/>
+                <a16:creationId xmlns:a16="http://schemas.microsoft.com/office/drawing/2014/main" id="{5F5E2702-9552-1F99-49DA-25149C04CE57}"/>
               </a:ext>
             </a:extLst>
           </p:cNvPr>
@@ -16332,8 +16332,8 @@
         </p:blipFill>
         <p:spPr>
           <a:xfrm>
-            <a:off x="2249002" y="19785009"/>
-            <a:ext cx="8245995" cy="4727704"/>
+            <a:off x="757856" y="20027698"/>
+            <a:ext cx="11357998" cy="4391759"/>
           </a:xfrm>
           <a:prstGeom prst="rect">
             <a:avLst/>

</xml_diff>